<commit_message>
docs: rebuild project diagrams as draw.io sources
Recreate the use-case, DFD level 0/1, Gantt, both activity diagrams and
the ER model as native draw.io files, checked against the Django code:

- DFD level 1 now uses six processes that match the views, with eight
  model-backed stores, and balances with level 0.
- Activity diagrams use role swimlanes and only the decisions the code
  makes (required-item check, duplicate/late rejection, upload limits,
  score <= max).
- The ER model shows every foreign key, including the four User links,
  the unique constraints and the one-to-one Grade.
- The Gantt chart follows the Week 4-7 journals and marks Week 3 as
  reconstructed.

Exports now come from draw.io Desktop through `make diagrams`. The two
Python generators that rewrote the .drawio files were removed, so they
can no longer overwrite edited sources. The proposal PDF and the Week 7
deck (diagram slides only, text and notes unchanged) were rebuilt.
</commit_message>
<xml_diff>
--- a/docs/submission/01-presentation/DeadlineDesk_Week7_Presentation.pptx
+++ b/docs/submission/01-presentation/DeadlineDesk_Week7_Presentation.pptx
@@ -5253,24 +5253,26 @@
           </a:p>
         </p:txBody>
       </p:sp>
-      <p:pic>
+      <p:pic xmlns:a="http://schemas.openxmlformats.org/drawingml/2006/main" xmlns:r="http://schemas.openxmlformats.org/officeDocument/2006/relationships">
         <p:nvPicPr>
-          <p:cNvPr id="14" name=""/>
+          <p:cNvPr id="15" name="" descr="gantt-chart.png"/>
           <p:cNvPicPr>
-            <a:picLocks xmlns:a="http://schemas.openxmlformats.org/drawingml/2006/main" noChangeAspect="1"/>
+            <a:picLocks noChangeAspect="1"/>
           </p:cNvPicPr>
           <p:nvPr/>
         </p:nvPicPr>
         <p:blipFill>
-          <a:blip xmlns:r="http://schemas.openxmlformats.org/officeDocument/2006/relationships" xmlns:a="http://schemas.openxmlformats.org/drawingml/2006/main" r:embed="R65f5d4c840264fd8"/>
-          <a:stretch xmlns:a="http://schemas.openxmlformats.org/drawingml/2006/main"/>
+          <a:blip r:embed="rId4"/>
+          <a:stretch>
+            <a:fillRect/>
+          </a:stretch>
         </p:blipFill>
         <p:spPr>
-          <a:xfrm xmlns:a="http://schemas.openxmlformats.org/drawingml/2006/main">
-            <a:off x="523875" y="1323957"/>
-            <a:ext cx="11144250" cy="4867311"/>
-          </a:xfrm>
-          <a:prstGeom xmlns:a="http://schemas.openxmlformats.org/drawingml/2006/main" prst="rect">
+          <a:xfrm>
+            <a:off x="2462547" y="1322000"/>
+            <a:ext cx="7266907" cy="4870000"/>
+          </a:xfrm>
+          <a:prstGeom prst="rect">
             <a:avLst/>
           </a:prstGeom>
         </p:spPr>
@@ -6703,24 +6705,26 @@
           </a:p>
         </p:txBody>
       </p:sp>
-      <p:pic>
+      <p:pic xmlns:a="http://schemas.openxmlformats.org/drawingml/2006/main" xmlns:r="http://schemas.openxmlformats.org/officeDocument/2006/relationships">
         <p:nvPicPr>
-          <p:cNvPr id="14" name=""/>
+          <p:cNvPr id="15" name="" descr="activity-placement.png"/>
           <p:cNvPicPr>
-            <a:picLocks xmlns:a="http://schemas.openxmlformats.org/drawingml/2006/main" noChangeAspect="1"/>
+            <a:picLocks noChangeAspect="1"/>
           </p:cNvPicPr>
           <p:nvPr/>
         </p:nvPicPr>
         <p:blipFill>
-          <a:blip xmlns:r="http://schemas.openxmlformats.org/officeDocument/2006/relationships" xmlns:a="http://schemas.openxmlformats.org/drawingml/2006/main" r:embed="R9a94b8f1e3724d01"/>
-          <a:stretch xmlns:a="http://schemas.openxmlformats.org/drawingml/2006/main"/>
+          <a:blip r:embed="rId4"/>
+          <a:stretch>
+            <a:fillRect/>
+          </a:stretch>
         </p:blipFill>
         <p:spPr>
-          <a:xfrm xmlns:a="http://schemas.openxmlformats.org/drawingml/2006/main">
-            <a:off x="523875" y="1491053"/>
-            <a:ext cx="11144250" cy="4533118"/>
-          </a:xfrm>
-          <a:prstGeom xmlns:a="http://schemas.openxmlformats.org/drawingml/2006/main" prst="rect">
+          <a:xfrm>
+            <a:off x="523875" y="1332951"/>
+            <a:ext cx="11144250" cy="4848099"/>
+          </a:xfrm>
+          <a:prstGeom prst="rect">
             <a:avLst/>
           </a:prstGeom>
         </p:spPr>
@@ -7021,24 +7025,26 @@
           </a:p>
         </p:txBody>
       </p:sp>
-      <p:pic>
+      <p:pic xmlns:a="http://schemas.openxmlformats.org/drawingml/2006/main" xmlns:r="http://schemas.openxmlformats.org/officeDocument/2006/relationships">
         <p:nvPicPr>
-          <p:cNvPr id="14" name=""/>
+          <p:cNvPr id="15" name="" descr="activity-academic.png"/>
           <p:cNvPicPr>
-            <a:picLocks xmlns:a="http://schemas.openxmlformats.org/drawingml/2006/main" noChangeAspect="1"/>
+            <a:picLocks noChangeAspect="1"/>
           </p:cNvPicPr>
           <p:nvPr/>
         </p:nvPicPr>
         <p:blipFill>
-          <a:blip xmlns:r="http://schemas.openxmlformats.org/officeDocument/2006/relationships" xmlns:a="http://schemas.openxmlformats.org/drawingml/2006/main" r:embed="Rc1898c71bc23476b"/>
-          <a:stretch xmlns:a="http://schemas.openxmlformats.org/drawingml/2006/main"/>
+          <a:blip r:embed="rId4"/>
+          <a:stretch>
+            <a:fillRect/>
+          </a:stretch>
         </p:blipFill>
         <p:spPr>
-          <a:xfrm xmlns:a="http://schemas.openxmlformats.org/drawingml/2006/main">
-            <a:off x="523875" y="1789057"/>
-            <a:ext cx="11144250" cy="3937112"/>
-          </a:xfrm>
-          <a:prstGeom xmlns:a="http://schemas.openxmlformats.org/drawingml/2006/main" prst="rect">
+          <a:xfrm>
+            <a:off x="523875" y="1620902"/>
+            <a:ext cx="11144250" cy="4272196"/>
+          </a:xfrm>
+          <a:prstGeom prst="rect">
             <a:avLst/>
           </a:prstGeom>
         </p:spPr>
@@ -7339,24 +7345,26 @@
           </a:p>
         </p:txBody>
       </p:sp>
-      <p:pic>
+      <p:pic xmlns:a="http://schemas.openxmlformats.org/drawingml/2006/main" xmlns:r="http://schemas.openxmlformats.org/officeDocument/2006/relationships">
         <p:nvPicPr>
-          <p:cNvPr id="14" name=""/>
+          <p:cNvPr id="15" name="" descr="er-placement-view.png"/>
           <p:cNvPicPr>
-            <a:picLocks xmlns:a="http://schemas.openxmlformats.org/drawingml/2006/main" noChangeAspect="1"/>
+            <a:picLocks noChangeAspect="1"/>
           </p:cNvPicPr>
           <p:nvPr/>
         </p:nvPicPr>
         <p:blipFill>
-          <a:blip xmlns:r="http://schemas.openxmlformats.org/officeDocument/2006/relationships" xmlns:a="http://schemas.openxmlformats.org/drawingml/2006/main" r:embed="Re59bfe8181e54768"/>
-          <a:stretch xmlns:a="http://schemas.openxmlformats.org/drawingml/2006/main"/>
+          <a:blip r:embed="rId4"/>
+          <a:stretch>
+            <a:fillRect/>
+          </a:stretch>
         </p:blipFill>
         <p:spPr>
-          <a:xfrm xmlns:a="http://schemas.openxmlformats.org/drawingml/2006/main">
-            <a:off x="523875" y="1366436"/>
-            <a:ext cx="11144250" cy="4829977"/>
-          </a:xfrm>
-          <a:prstGeom xmlns:a="http://schemas.openxmlformats.org/drawingml/2006/main" prst="rect">
+          <a:xfrm>
+            <a:off x="3129219" y="1322000"/>
+            <a:ext cx="5933563" cy="4870000"/>
+          </a:xfrm>
+          <a:prstGeom prst="rect">
             <a:avLst/>
           </a:prstGeom>
         </p:spPr>
@@ -7657,24 +7665,26 @@
           </a:p>
         </p:txBody>
       </p:sp>
-      <p:pic>
+      <p:pic xmlns:a="http://schemas.openxmlformats.org/drawingml/2006/main" xmlns:r="http://schemas.openxmlformats.org/officeDocument/2006/relationships">
         <p:nvPicPr>
-          <p:cNvPr id="14" name=""/>
+          <p:cNvPr id="15" name="" descr="er-academic-view.png"/>
           <p:cNvPicPr>
-            <a:picLocks xmlns:a="http://schemas.openxmlformats.org/drawingml/2006/main" noChangeAspect="1"/>
+            <a:picLocks noChangeAspect="1"/>
           </p:cNvPicPr>
           <p:nvPr/>
         </p:nvPicPr>
         <p:blipFill>
-          <a:blip xmlns:r="http://schemas.openxmlformats.org/officeDocument/2006/relationships" xmlns:a="http://schemas.openxmlformats.org/drawingml/2006/main" r:embed="R20da499bf4334de4"/>
-          <a:stretch xmlns:a="http://schemas.openxmlformats.org/drawingml/2006/main"/>
+          <a:blip r:embed="rId4"/>
+          <a:stretch>
+            <a:fillRect/>
+          </a:stretch>
         </p:blipFill>
         <p:spPr>
-          <a:xfrm xmlns:a="http://schemas.openxmlformats.org/drawingml/2006/main">
-            <a:off x="523875" y="1552308"/>
-            <a:ext cx="11144250" cy="4458235"/>
-          </a:xfrm>
-          <a:prstGeom xmlns:a="http://schemas.openxmlformats.org/drawingml/2006/main" prst="rect">
+          <a:xfrm>
+            <a:off x="3977271" y="1322000"/>
+            <a:ext cx="4237459" cy="4870000"/>
+          </a:xfrm>
+          <a:prstGeom prst="rect">
             <a:avLst/>
           </a:prstGeom>
         </p:spPr>

</xml_diff>